<commit_message>
Add Tools & thinking slide (tool per visual + why AI) to site, pptx and PDF
Co-Authored-By: Claude Opus 5.5 <noreply@anthropic.com>
</commit_message>
<xml_diff>
--- a/INFUSE-Academy-visuals.pptx
+++ b/INFUSE-Academy-visuals.pptx
@@ -8,6 +8,7 @@
     <p:sldId id="256" r:id="rId7"/>
     <p:sldId id="257" r:id="rId9"/>
     <p:sldId id="258" r:id="rId10"/>
+    <p:sldId id="259" r:id="rId11"/>
   </p:sldIdLst>
   <p:sldSz cx="12192000" cy="6858000" type="screen4x3"/>
   <p:notesSz cx="6858000" cy="9144000"/>
@@ -645,6 +646,76 @@
           <a:p>
             <a:r>
               <a:t>Tools: built in code (HTML, SVG, Canvas) with Claude (Anthropic); typography Asap; INFUSE Academy palette. Animated version: see the live link.</a:t>
+            </a:r>
+          </a:p>
+        </p:txBody>
+      </p:sp>
+      <p:sp>
+        <p:nvSpPr>
+          <p:cNvPr id="4" name="Slide Number Placeholder 3"/>
+          <p:cNvSpPr>
+            <a:spLocks noGrp="1"/>
+          </p:cNvSpPr>
+          <p:nvPr>
+            <p:ph type="sldNum" idx="5" sz="quarter"/>
+          </p:nvPr>
+        </p:nvSpPr>
+        <p:spPr/>
+      </p:sp>
+    </p:spTree>
+  </p:cSld>
+  <p:clrMapOvr>
+    <a:masterClrMapping/>
+  </p:clrMapOvr>
+</p:notes>
+</file>
+
+<file path=ppt/notesSlides/notesSlide4.xml><?xml version="1.0" encoding="utf-8"?>
+<p:notes xmlns:a="http://schemas.openxmlformats.org/drawingml/2006/main" xmlns:p="http://schemas.openxmlformats.org/presentationml/2006/main" xmlns:r="http://schemas.openxmlformats.org/officeDocument/2006/relationships">
+  <p:cSld>
+    <p:spTree>
+      <p:nvGrpSpPr>
+        <p:cNvPr id="1" name=""/>
+        <p:cNvGrpSpPr/>
+        <p:nvPr/>
+      </p:nvGrpSpPr>
+      <p:grpSpPr>
+        <a:xfrm>
+          <a:off x="0" y="0"/>
+          <a:ext cx="0" cy="0"/>
+          <a:chOff x="0" y="0"/>
+          <a:chExt cx="0" cy="0"/>
+        </a:xfrm>
+      </p:grpSpPr>
+      <p:sp>
+        <p:nvSpPr>
+          <p:cNvPr id="2" name="Slide Image Placeholder 1"/>
+          <p:cNvSpPr>
+            <a:spLocks noGrp="1"/>
+          </p:cNvSpPr>
+          <p:nvPr>
+            <p:ph type="sldImg" idx="2"/>
+          </p:nvPr>
+        </p:nvSpPr>
+        <p:spPr/>
+      </p:sp>
+      <p:sp>
+        <p:nvSpPr>
+          <p:cNvPr id="3" name="Notes Placeholder 2"/>
+          <p:cNvSpPr>
+            <a:spLocks noGrp="1"/>
+          </p:cNvSpPr>
+          <p:nvPr>
+            <p:ph type="body" idx="3" sz="quarter"/>
+          </p:nvPr>
+        </p:nvSpPr>
+        <p:spPr/>
+        <p:txBody>
+          <a:bodyPr/>
+          <a:lstStyle/>
+          <a:p>
+            <a:r>
+              <a:t>Process slide: tools used per visual and why AI.</a:t>
             </a:r>
           </a:p>
         </p:txBody>
@@ -4854,6 +4925,715 @@
                 <a:latin typeface="Asap"/>
               </a:rPr>
               <a:t>Nobody is using it. The gap was there on day one.</a:t>
+            </a:r>
+          </a:p>
+        </p:txBody>
+      </p:sp>
+    </p:spTree>
+  </p:cSld>
+  <p:clrMapOvr>
+    <a:masterClrMapping/>
+  </p:clrMapOvr>
+</p:sld>
+</file>
+
+<file path=ppt/slides/slide4.xml><?xml version="1.0" encoding="utf-8"?>
+<p:sld xmlns:a="http://schemas.openxmlformats.org/drawingml/2006/main" xmlns:p="http://schemas.openxmlformats.org/presentationml/2006/main" xmlns:r="http://schemas.openxmlformats.org/officeDocument/2006/relationships">
+  <p:cSld>
+    <p:spTree>
+      <p:nvGrpSpPr>
+        <p:cNvPr id="1" name=""/>
+        <p:cNvGrpSpPr/>
+        <p:nvPr/>
+      </p:nvGrpSpPr>
+      <p:grpSpPr/>
+      <p:pic>
+        <p:nvPicPr>
+          <p:cNvPr id="2" name="Picture 1" descr="04-clean.png"/>
+          <p:cNvPicPr>
+            <a:picLocks noChangeAspect="1"/>
+          </p:cNvPicPr>
+          <p:nvPr/>
+        </p:nvPicPr>
+        <p:blipFill>
+          <a:blip r:embed="rId2"/>
+          <a:stretch>
+            <a:fillRect/>
+          </a:stretch>
+        </p:blipFill>
+        <p:spPr>
+          <a:xfrm>
+            <a:off x="0" y="0"/>
+            <a:ext cx="12192000" cy="6858000"/>
+          </a:xfrm>
+          <a:prstGeom prst="rect">
+            <a:avLst/>
+          </a:prstGeom>
+        </p:spPr>
+      </p:pic>
+      <p:sp>
+        <p:nvSpPr>
+          <p:cNvPr id="3" name="Rounded Rectangle 2"/>
+          <p:cNvSpPr/>
+          <p:nvPr/>
+        </p:nvSpPr>
+        <p:spPr>
+          <a:xfrm>
+            <a:off x="698500" y="596900"/>
+            <a:ext cx="254000" cy="25400"/>
+          </a:xfrm>
+          <a:prstGeom prst="roundRect">
+            <a:avLst/>
+          </a:prstGeom>
+          <a:solidFill>
+            <a:srgbClr val="FF4F28"/>
+          </a:solidFill>
+          <a:ln>
+            <a:noFill/>
+          </a:ln>
+        </p:spPr>
+        <p:style>
+          <a:lnRef idx="1">
+            <a:schemeClr val="accent1"/>
+          </a:lnRef>
+          <a:fillRef idx="3">
+            <a:schemeClr val="accent1"/>
+          </a:fillRef>
+          <a:effectRef idx="2">
+            <a:schemeClr val="accent1"/>
+          </a:effectRef>
+          <a:fontRef idx="minor">
+            <a:schemeClr val="lt1"/>
+          </a:fontRef>
+        </p:style>
+        <p:txBody>
+          <a:bodyPr rtlCol="0" anchor="ctr"/>
+          <a:lstStyle/>
+          <a:p>
+            <a:pPr algn="ctr"/>
+          </a:p>
+        </p:txBody>
+      </p:sp>
+      <p:sp>
+        <p:nvSpPr>
+          <p:cNvPr id="4" name="TextBox 3"/>
+          <p:cNvSpPr txBox="1"/>
+          <p:nvPr/>
+        </p:nvSpPr>
+        <p:spPr>
+          <a:xfrm>
+            <a:off x="1054100" y="533400"/>
+            <a:ext cx="3175000" cy="190500"/>
+          </a:xfrm>
+          <a:prstGeom prst="rect">
+            <a:avLst/>
+          </a:prstGeom>
+          <a:noFill/>
+        </p:spPr>
+        <p:txBody>
+          <a:bodyPr wrap="none" lIns="0" rIns="0" tIns="0" bIns="0" anchor="t">
+            <a:spAutoFit/>
+          </a:bodyPr>
+          <a:lstStyle/>
+          <a:p>
+            <a:pPr algn="l">
+              <a:lnSpc>
+                <a:spcPts val="1264"/>
+              </a:lnSpc>
+            </a:pPr>
+            <a:r>
+              <a:rPr sz="1100" b="1" spc="242">
+                <a:solidFill>
+                  <a:srgbClr val="FF4F28"/>
+                </a:solidFill>
+                <a:latin typeface="Asap"/>
+              </a:rPr>
+              <a:t>04  PROCESS</a:t>
+            </a:r>
+          </a:p>
+        </p:txBody>
+      </p:sp>
+      <p:sp>
+        <p:nvSpPr>
+          <p:cNvPr id="5" name="TextBox 4"/>
+          <p:cNvSpPr txBox="1"/>
+          <p:nvPr/>
+        </p:nvSpPr>
+        <p:spPr>
+          <a:xfrm>
+            <a:off x="673100" y="787400"/>
+            <a:ext cx="6350000" cy="571500"/>
+          </a:xfrm>
+          <a:prstGeom prst="rect">
+            <a:avLst/>
+          </a:prstGeom>
+          <a:noFill/>
+        </p:spPr>
+        <p:txBody>
+          <a:bodyPr wrap="none" lIns="0" rIns="0" tIns="0" bIns="0" anchor="t">
+            <a:spAutoFit/>
+          </a:bodyPr>
+          <a:lstStyle/>
+          <a:p>
+            <a:pPr algn="l">
+              <a:lnSpc>
+                <a:spcPts val="3960"/>
+              </a:lnSpc>
+            </a:pPr>
+            <a:r>
+              <a:rPr sz="3600" b="1" spc="-101">
+                <a:solidFill>
+                  <a:srgbClr val="021A36"/>
+                </a:solidFill>
+                <a:latin typeface="Asap"/>
+              </a:rPr>
+              <a:t>Tools &amp; thinking</a:t>
+            </a:r>
+          </a:p>
+        </p:txBody>
+      </p:sp>
+      <p:sp>
+        <p:nvSpPr>
+          <p:cNvPr id="6" name="TextBox 5"/>
+          <p:cNvSpPr txBox="1"/>
+          <p:nvPr/>
+        </p:nvSpPr>
+        <p:spPr>
+          <a:xfrm>
+            <a:off x="1358900" y="1943100"/>
+            <a:ext cx="2667000" cy="279400"/>
+          </a:xfrm>
+          <a:prstGeom prst="rect">
+            <a:avLst/>
+          </a:prstGeom>
+          <a:noFill/>
+        </p:spPr>
+        <p:txBody>
+          <a:bodyPr wrap="none" lIns="0" rIns="0" tIns="0" bIns="0" anchor="t">
+            <a:spAutoFit/>
+          </a:bodyPr>
+          <a:lstStyle/>
+          <a:p>
+            <a:pPr algn="l">
+              <a:lnSpc>
+                <a:spcPts val="1839"/>
+              </a:lnSpc>
+            </a:pPr>
+            <a:r>
+              <a:rPr sz="1600" b="1" spc="-32">
+                <a:solidFill>
+                  <a:srgbClr val="021A36"/>
+                </a:solidFill>
+                <a:latin typeface="Asap"/>
+              </a:rPr>
+              <a:t>A beginning</a:t>
+            </a:r>
+          </a:p>
+        </p:txBody>
+      </p:sp>
+      <p:sp>
+        <p:nvSpPr>
+          <p:cNvPr id="7" name="TextBox 6"/>
+          <p:cNvSpPr txBox="1"/>
+          <p:nvPr/>
+        </p:nvSpPr>
+        <p:spPr>
+          <a:xfrm>
+            <a:off x="952500" y="2438400"/>
+            <a:ext cx="1905000" cy="139700"/>
+          </a:xfrm>
+          <a:prstGeom prst="rect">
+            <a:avLst/>
+          </a:prstGeom>
+          <a:noFill/>
+        </p:spPr>
+        <p:txBody>
+          <a:bodyPr wrap="none" lIns="0" rIns="0" tIns="0" bIns="0" anchor="t">
+            <a:spAutoFit/>
+          </a:bodyPr>
+          <a:lstStyle/>
+          <a:p>
+            <a:pPr algn="l">
+              <a:lnSpc>
+                <a:spcPts val="919"/>
+              </a:lnSpc>
+            </a:pPr>
+            <a:r>
+              <a:rPr sz="800" b="1" spc="144">
+                <a:solidFill>
+                  <a:srgbClr val="FF4F28"/>
+                </a:solidFill>
+                <a:latin typeface="Asap"/>
+              </a:rPr>
+              <a:t>TOOL</a:t>
+            </a:r>
+          </a:p>
+        </p:txBody>
+      </p:sp>
+      <p:sp>
+        <p:nvSpPr>
+          <p:cNvPr id="8" name="TextBox 7"/>
+          <p:cNvSpPr txBox="1"/>
+          <p:nvPr/>
+        </p:nvSpPr>
+        <p:spPr>
+          <a:xfrm>
+            <a:off x="952500" y="2603500"/>
+            <a:ext cx="2984500" cy="190500"/>
+          </a:xfrm>
+          <a:prstGeom prst="rect">
+            <a:avLst/>
+          </a:prstGeom>
+          <a:noFill/>
+        </p:spPr>
+        <p:txBody>
+          <a:bodyPr wrap="none" lIns="0" rIns="0" tIns="0" bIns="0" anchor="t">
+            <a:spAutoFit/>
+          </a:bodyPr>
+          <a:lstStyle/>
+          <a:p>
+            <a:pPr algn="l">
+              <a:lnSpc>
+                <a:spcPts val="1264"/>
+              </a:lnSpc>
+            </a:pPr>
+            <a:r>
+              <a:rPr sz="1100" b="1">
+                <a:solidFill>
+                  <a:srgbClr val="021A36"/>
+                </a:solidFill>
+                <a:latin typeface="Asap"/>
+              </a:rPr>
+              <a:t>Claude (Anthropic) → HTML + SVG</a:t>
+            </a:r>
+          </a:p>
+        </p:txBody>
+      </p:sp>
+      <p:sp>
+        <p:nvSpPr>
+          <p:cNvPr id="9" name="TextBox 8"/>
+          <p:cNvSpPr txBox="1"/>
+          <p:nvPr/>
+        </p:nvSpPr>
+        <p:spPr>
+          <a:xfrm>
+            <a:off x="952500" y="2933700"/>
+            <a:ext cx="2921000" cy="1524000"/>
+          </a:xfrm>
+          <a:prstGeom prst="rect">
+            <a:avLst/>
+          </a:prstGeom>
+          <a:noFill/>
+        </p:spPr>
+        <p:txBody>
+          <a:bodyPr wrap="square" lIns="0" rIns="0" tIns="0" bIns="0" anchor="t">
+            <a:spAutoFit/>
+          </a:bodyPr>
+          <a:lstStyle/>
+          <a:p>
+            <a:pPr algn="l">
+              <a:lnSpc>
+                <a:spcPts val="1522"/>
+              </a:lnSpc>
+            </a:pPr>
+            <a:r>
+              <a:rPr sz="1050" b="0">
+                <a:solidFill>
+                  <a:srgbClr val="3A4A5C"/>
+                </a:solidFill>
+                <a:latin typeface="Asap"/>
+              </a:rPr>
+              <a:t>“Hard” had to look genuinely overwhelming, so the knot is generated from hundreds of random loops and never looks tidy. Against that chaos, one orange thread does the only thing that matters: it leaves. The eye follows it to a single dot that says “start here”.</a:t>
+            </a:r>
+          </a:p>
+        </p:txBody>
+      </p:sp>
+      <p:sp>
+        <p:nvSpPr>
+          <p:cNvPr id="10" name="TextBox 9"/>
+          <p:cNvSpPr txBox="1"/>
+          <p:nvPr/>
+        </p:nvSpPr>
+        <p:spPr>
+          <a:xfrm>
+            <a:off x="5041900" y="1943100"/>
+            <a:ext cx="2667000" cy="279400"/>
+          </a:xfrm>
+          <a:prstGeom prst="rect">
+            <a:avLst/>
+          </a:prstGeom>
+          <a:noFill/>
+        </p:spPr>
+        <p:txBody>
+          <a:bodyPr wrap="none" lIns="0" rIns="0" tIns="0" bIns="0" anchor="t">
+            <a:spAutoFit/>
+          </a:bodyPr>
+          <a:lstStyle/>
+          <a:p>
+            <a:pPr algn="l">
+              <a:lnSpc>
+                <a:spcPts val="1839"/>
+              </a:lnSpc>
+            </a:pPr>
+            <a:r>
+              <a:rPr sz="1600" b="1" spc="-32">
+                <a:solidFill>
+                  <a:srgbClr val="021A36"/>
+                </a:solidFill>
+                <a:latin typeface="Asap"/>
+              </a:rPr>
+              <a:t>The dark funnel</a:t>
+            </a:r>
+          </a:p>
+        </p:txBody>
+      </p:sp>
+      <p:sp>
+        <p:nvSpPr>
+          <p:cNvPr id="11" name="TextBox 10"/>
+          <p:cNvSpPr txBox="1"/>
+          <p:nvPr/>
+        </p:nvSpPr>
+        <p:spPr>
+          <a:xfrm>
+            <a:off x="4635500" y="2438400"/>
+            <a:ext cx="1905000" cy="139700"/>
+          </a:xfrm>
+          <a:prstGeom prst="rect">
+            <a:avLst/>
+          </a:prstGeom>
+          <a:noFill/>
+        </p:spPr>
+        <p:txBody>
+          <a:bodyPr wrap="none" lIns="0" rIns="0" tIns="0" bIns="0" anchor="t">
+            <a:spAutoFit/>
+          </a:bodyPr>
+          <a:lstStyle/>
+          <a:p>
+            <a:pPr algn="l">
+              <a:lnSpc>
+                <a:spcPts val="919"/>
+              </a:lnSpc>
+            </a:pPr>
+            <a:r>
+              <a:rPr sz="800" b="1" spc="144">
+                <a:solidFill>
+                  <a:srgbClr val="FF4F28"/>
+                </a:solidFill>
+                <a:latin typeface="Asap"/>
+              </a:rPr>
+              <a:t>TOOL</a:t>
+            </a:r>
+          </a:p>
+        </p:txBody>
+      </p:sp>
+      <p:sp>
+        <p:nvSpPr>
+          <p:cNvPr id="12" name="TextBox 11"/>
+          <p:cNvSpPr txBox="1"/>
+          <p:nvPr/>
+        </p:nvSpPr>
+        <p:spPr>
+          <a:xfrm>
+            <a:off x="4635500" y="2603500"/>
+            <a:ext cx="2984500" cy="190500"/>
+          </a:xfrm>
+          <a:prstGeom prst="rect">
+            <a:avLst/>
+          </a:prstGeom>
+          <a:noFill/>
+        </p:spPr>
+        <p:txBody>
+          <a:bodyPr wrap="none" lIns="0" rIns="0" tIns="0" bIns="0" anchor="t">
+            <a:spAutoFit/>
+          </a:bodyPr>
+          <a:lstStyle/>
+          <a:p>
+            <a:pPr algn="l">
+              <a:lnSpc>
+                <a:spcPts val="1264"/>
+              </a:lnSpc>
+            </a:pPr>
+            <a:r>
+              <a:rPr sz="1100" b="1">
+                <a:solidFill>
+                  <a:srgbClr val="021A36"/>
+                </a:solidFill>
+                <a:latin typeface="Asap"/>
+              </a:rPr>
+              <a:t>Claude (Anthropic) → HTML Canvas</a:t>
+            </a:r>
+          </a:p>
+        </p:txBody>
+      </p:sp>
+      <p:sp>
+        <p:nvSpPr>
+          <p:cNvPr id="13" name="TextBox 12"/>
+          <p:cNvSpPr txBox="1"/>
+          <p:nvPr/>
+        </p:nvSpPr>
+        <p:spPr>
+          <a:xfrm>
+            <a:off x="4635500" y="2933700"/>
+            <a:ext cx="2921000" cy="1524000"/>
+          </a:xfrm>
+          <a:prstGeom prst="rect">
+            <a:avLst/>
+          </a:prstGeom>
+          <a:noFill/>
+        </p:spPr>
+        <p:txBody>
+          <a:bodyPr wrap="square" lIns="0" rIns="0" tIns="0" bIns="0" anchor="t">
+            <a:spAutoFit/>
+          </a:bodyPr>
+          <a:lstStyle/>
+          <a:p>
+            <a:pPr algn="l">
+              <a:lnSpc>
+                <a:spcPts val="1522"/>
+              </a:lnSpc>
+            </a:pPr>
+            <a:r>
+              <a:rPr sz="1050" b="0">
+                <a:solidFill>
+                  <a:srgbClr val="3A4A5C"/>
+                </a:solidFill>
+                <a:latin typeface="Asap"/>
+              </a:rPr>
+              <a:t>A statistic is easy to read and easy to forget, so the 61% becomes physical: buyers flow through a funnel and most of their journey happens in the dark. In the live version your cursor is a flashlight, so you literally have to go looking for them.</a:t>
+            </a:r>
+          </a:p>
+        </p:txBody>
+      </p:sp>
+      <p:sp>
+        <p:nvSpPr>
+          <p:cNvPr id="14" name="TextBox 13"/>
+          <p:cNvSpPr txBox="1"/>
+          <p:nvPr/>
+        </p:nvSpPr>
+        <p:spPr>
+          <a:xfrm>
+            <a:off x="8724900" y="1943100"/>
+            <a:ext cx="2667000" cy="279400"/>
+          </a:xfrm>
+          <a:prstGeom prst="rect">
+            <a:avLst/>
+          </a:prstGeom>
+          <a:noFill/>
+        </p:spPr>
+        <p:txBody>
+          <a:bodyPr wrap="none" lIns="0" rIns="0" tIns="0" bIns="0" anchor="t">
+            <a:spAutoFit/>
+          </a:bodyPr>
+          <a:lstStyle/>
+          <a:p>
+            <a:pPr algn="l">
+              <a:lnSpc>
+                <a:spcPts val="1839"/>
+              </a:lnSpc>
+            </a:pPr>
+            <a:r>
+              <a:rPr sz="1600" b="1" spc="-32">
+                <a:solidFill>
+                  <a:srgbClr val="021A36"/>
+                </a:solidFill>
+                <a:latin typeface="Asap"/>
+              </a:rPr>
+              <a:t>The script</a:t>
+            </a:r>
+          </a:p>
+        </p:txBody>
+      </p:sp>
+      <p:sp>
+        <p:nvSpPr>
+          <p:cNvPr id="15" name="TextBox 14"/>
+          <p:cNvSpPr txBox="1"/>
+          <p:nvPr/>
+        </p:nvSpPr>
+        <p:spPr>
+          <a:xfrm>
+            <a:off x="8318500" y="2438400"/>
+            <a:ext cx="1905000" cy="139700"/>
+          </a:xfrm>
+          <a:prstGeom prst="rect">
+            <a:avLst/>
+          </a:prstGeom>
+          <a:noFill/>
+        </p:spPr>
+        <p:txBody>
+          <a:bodyPr wrap="none" lIns="0" rIns="0" tIns="0" bIns="0" anchor="t">
+            <a:spAutoFit/>
+          </a:bodyPr>
+          <a:lstStyle/>
+          <a:p>
+            <a:pPr algn="l">
+              <a:lnSpc>
+                <a:spcPts val="919"/>
+              </a:lnSpc>
+            </a:pPr>
+            <a:r>
+              <a:rPr sz="800" b="1" spc="144">
+                <a:solidFill>
+                  <a:srgbClr val="FF4F28"/>
+                </a:solidFill>
+                <a:latin typeface="Asap"/>
+              </a:rPr>
+              <a:t>TOOL</a:t>
+            </a:r>
+          </a:p>
+        </p:txBody>
+      </p:sp>
+      <p:sp>
+        <p:nvSpPr>
+          <p:cNvPr id="16" name="TextBox 15"/>
+          <p:cNvSpPr txBox="1"/>
+          <p:nvPr/>
+        </p:nvSpPr>
+        <p:spPr>
+          <a:xfrm>
+            <a:off x="8318500" y="2603500"/>
+            <a:ext cx="2984500" cy="190500"/>
+          </a:xfrm>
+          <a:prstGeom prst="rect">
+            <a:avLst/>
+          </a:prstGeom>
+          <a:noFill/>
+        </p:spPr>
+        <p:txBody>
+          <a:bodyPr wrap="none" lIns="0" rIns="0" tIns="0" bIns="0" anchor="t">
+            <a:spAutoFit/>
+          </a:bodyPr>
+          <a:lstStyle/>
+          <a:p>
+            <a:pPr algn="l">
+              <a:lnSpc>
+                <a:spcPts val="1264"/>
+              </a:lnSpc>
+            </a:pPr>
+            <a:r>
+              <a:rPr sz="1100" b="1">
+                <a:solidFill>
+                  <a:srgbClr val="021A36"/>
+                </a:solidFill>
+                <a:latin typeface="Asap"/>
+              </a:rPr>
+              <a:t>Claude (Anthropic) → HTML + SVG</a:t>
+            </a:r>
+          </a:p>
+        </p:txBody>
+      </p:sp>
+      <p:sp>
+        <p:nvSpPr>
+          <p:cNvPr id="17" name="TextBox 16"/>
+          <p:cNvSpPr txBox="1"/>
+          <p:nvPr/>
+        </p:nvSpPr>
+        <p:spPr>
+          <a:xfrm>
+            <a:off x="8318500" y="2933700"/>
+            <a:ext cx="2921000" cy="1524000"/>
+          </a:xfrm>
+          <a:prstGeom prst="rect">
+            <a:avLst/>
+          </a:prstGeom>
+          <a:noFill/>
+        </p:spPr>
+        <p:txBody>
+          <a:bodyPr wrap="square" lIns="0" rIns="0" tIns="0" bIns="0" anchor="t">
+            <a:spAutoFit/>
+          </a:bodyPr>
+          <a:lstStyle/>
+          <a:p>
+            <a:pPr algn="l">
+              <a:lnSpc>
+                <a:spcPts val="1522"/>
+              </a:lnSpc>
+            </a:pPr>
+            <a:r>
+              <a:rPr sz="1050" b="0">
+                <a:solidFill>
+                  <a:srgbClr val="3A4A5C"/>
+                </a:solidFill>
+                <a:latin typeface="Asap"/>
+              </a:rPr>
+              <a:t>The story is about a gap too small to notice. Each panel shows the team drifting away from the platform while one line underneath shows why: a few degrees off on day one becomes a missed opportunity by month six. The panels darken as the story does.</a:t>
+            </a:r>
+          </a:p>
+        </p:txBody>
+      </p:sp>
+      <p:sp>
+        <p:nvSpPr>
+          <p:cNvPr id="18" name="TextBox 17"/>
+          <p:cNvSpPr txBox="1"/>
+          <p:nvPr/>
+        </p:nvSpPr>
+        <p:spPr>
+          <a:xfrm>
+            <a:off x="1003300" y="4940300"/>
+            <a:ext cx="1905000" cy="139700"/>
+          </a:xfrm>
+          <a:prstGeom prst="rect">
+            <a:avLst/>
+          </a:prstGeom>
+          <a:noFill/>
+        </p:spPr>
+        <p:txBody>
+          <a:bodyPr wrap="none" lIns="0" rIns="0" tIns="0" bIns="0" anchor="t">
+            <a:spAutoFit/>
+          </a:bodyPr>
+          <a:lstStyle/>
+          <a:p>
+            <a:pPr algn="l">
+              <a:lnSpc>
+                <a:spcPts val="919"/>
+              </a:lnSpc>
+            </a:pPr>
+            <a:r>
+              <a:rPr sz="800" b="1" spc="144">
+                <a:solidFill>
+                  <a:srgbClr val="78FFD6"/>
+                </a:solidFill>
+                <a:latin typeface="Asap"/>
+              </a:rPr>
+              <a:t>WHY AI</a:t>
+            </a:r>
+          </a:p>
+        </p:txBody>
+      </p:sp>
+      <p:sp>
+        <p:nvSpPr>
+          <p:cNvPr id="19" name="TextBox 18"/>
+          <p:cNvSpPr txBox="1"/>
+          <p:nvPr/>
+        </p:nvSpPr>
+        <p:spPr>
+          <a:xfrm>
+            <a:off x="1003300" y="5143500"/>
+            <a:ext cx="10185400" cy="698500"/>
+          </a:xfrm>
+          <a:prstGeom prst="rect">
+            <a:avLst/>
+          </a:prstGeom>
+          <a:noFill/>
+        </p:spPr>
+        <p:txBody>
+          <a:bodyPr wrap="square" lIns="0" rIns="0" tIns="0" bIns="0" anchor="t">
+            <a:spAutoFit/>
+          </a:bodyPr>
+          <a:lstStyle/>
+          <a:p>
+            <a:pPr algn="l">
+              <a:lnSpc>
+                <a:spcPts val="1704"/>
+              </a:lnSpc>
+            </a:pPr>
+            <a:r>
+              <a:rPr sz="1200" b="0">
+                <a:solidFill>
+                  <a:srgbClr val="FFFFFF"/>
+                </a:solidFill>
+                <a:latin typeface="Asap"/>
+              </a:rPr>
+              <a:t>I used Claude as a generative design partner: I set the concept, composition, palette and type, and it wrote the code that renders each visual — a procedural knot, a particle funnel, an animated storyboard. Code-generated art stays crisp at any size, animates for free and follows the brand system exactly, which image generators still struggle with.</a:t>
             </a:r>
           </a:p>
         </p:txBody>

</xml_diff>

<commit_message>
Slide 1: add AI-generated character (Magnific) holding the thread; credit tool in process slide
Co-Authored-By: Claude Opus 5.5 <noreply@anthropic.com>
</commit_message>
<xml_diff>
--- a/INFUSE-Academy-visuals.pptx
+++ b/INFUSE-Academy-visuals.pptx
@@ -505,7 +505,7 @@
           <a:lstStyle/>
           <a:p>
             <a:r>
-              <a:t>Tools: built in code (HTML, SVG, Canvas) with Claude (Anthropic); typography Asap; INFUSE Academy palette. Animated version: see the live link.</a:t>
+              <a:t>Tools: character generated in Magnific (slide 1); visuals built in code (HTML, SVG, Canvas) with Claude (Anthropic); typography Asap; INFUSE Academy palette. Animated version: see the live link.</a:t>
             </a:r>
           </a:p>
         </p:txBody>
@@ -575,7 +575,7 @@
           <a:lstStyle/>
           <a:p>
             <a:r>
-              <a:t>Tools: built in code (HTML, SVG, Canvas) with Claude (Anthropic); typography Asap; INFUSE Academy palette. Animated version: see the live link.</a:t>
+              <a:t>Tools: character generated in Magnific (slide 1); visuals built in code (HTML, SVG, Canvas) with Claude (Anthropic); typography Asap; INFUSE Academy palette. Animated version: see the live link.</a:t>
             </a:r>
           </a:p>
         </p:txBody>
@@ -645,7 +645,7 @@
           <a:lstStyle/>
           <a:p>
             <a:r>
-              <a:t>Tools: built in code (HTML, SVG, Canvas) with Claude (Anthropic); typography Asap; INFUSE Academy palette. Animated version: see the live link.</a:t>
+              <a:t>Tools: character generated in Magnific (slide 1); visuals built in code (HTML, SVG, Canvas) with Claude (Anthropic); typography Asap; INFUSE Academy palette. Animated version: see the live link.</a:t>
             </a:r>
           </a:p>
         </p:txBody>
@@ -3753,7 +3753,7 @@
         </p:nvSpPr>
         <p:spPr>
           <a:xfrm>
-            <a:off x="825500" y="774700"/>
+            <a:off x="825500" y="635000"/>
             <a:ext cx="254000" cy="25400"/>
           </a:xfrm>
           <a:prstGeom prst="roundRect">
@@ -3796,7 +3796,7 @@
         </p:nvSpPr>
         <p:spPr>
           <a:xfrm>
-            <a:off x="1181100" y="711200"/>
+            <a:off x="1181100" y="571500"/>
             <a:ext cx="3175000" cy="190500"/>
           </a:xfrm>
           <a:prstGeom prst="rect">
@@ -3835,7 +3835,7 @@
         </p:nvSpPr>
         <p:spPr>
           <a:xfrm>
-            <a:off x="800100" y="1092200"/>
+            <a:off x="800100" y="952500"/>
             <a:ext cx="5715000" cy="2730500"/>
           </a:xfrm>
           <a:prstGeom prst="rect">
@@ -3917,45 +3917,6 @@
       <p:sp>
         <p:nvSpPr>
           <p:cNvPr id="6" name="TextBox 5"/>
-          <p:cNvSpPr txBox="1"/>
-          <p:nvPr/>
-        </p:nvSpPr>
-        <p:spPr>
-          <a:xfrm>
-            <a:off x="825500" y="5549900"/>
-            <a:ext cx="2540000" cy="165100"/>
-          </a:xfrm>
-          <a:prstGeom prst="rect">
-            <a:avLst/>
-          </a:prstGeom>
-          <a:noFill/>
-        </p:spPr>
-        <p:txBody>
-          <a:bodyPr wrap="none" lIns="0" rIns="0" tIns="0" bIns="0" anchor="t">
-            <a:spAutoFit/>
-          </a:bodyPr>
-          <a:lstStyle/>
-          <a:p>
-            <a:pPr algn="l">
-              <a:lnSpc>
-                <a:spcPts val="1150"/>
-              </a:lnSpc>
-            </a:pPr>
-            <a:r>
-              <a:rPr sz="1000" b="1" spc="240">
-                <a:solidFill>
-                  <a:srgbClr val="021A36"/>
-                </a:solidFill>
-                <a:latin typeface="Asap"/>
-              </a:rPr>
-              <a:t>START HERE</a:t>
-            </a:r>
-          </a:p>
-        </p:txBody>
-      </p:sp>
-      <p:sp>
-        <p:nvSpPr>
-          <p:cNvPr id="7" name="TextBox 6"/>
           <p:cNvSpPr txBox="1"/>
           <p:nvPr/>
         </p:nvSpPr>
@@ -5204,7 +5165,7 @@
                 </a:solidFill>
                 <a:latin typeface="Asap"/>
               </a:rPr>
-              <a:t>Claude (Anthropic) → HTML + SVG</a:t>
+              <a:t>Magnific (character) + Claude → code</a:t>
             </a:r>
           </a:p>
         </p:txBody>
@@ -5243,7 +5204,7 @@
                 </a:solidFill>
                 <a:latin typeface="Asap"/>
               </a:rPr>
-              <a:t>“Hard” had to look genuinely overwhelming, so the knot is generated from hundreds of random loops and never looks tidy. Against that chaos, one orange thread does the only thing that matters: it leaves. The eye follows it to a single dot that says “start here”.</a:t>
+              <a:t>The character was generated with AI; the world around her is code. The knot is built from hundreds of random loops so “hard” looks genuinely overwhelming. One orange thread escapes the chaos and ends right at her fingertips: the beginning is always within reach.</a:t>
             </a:r>
           </a:p>
         </p:txBody>
@@ -5633,7 +5594,7 @@
                 </a:solidFill>
                 <a:latin typeface="Asap"/>
               </a:rPr>
-              <a:t>I used Claude as a generative design partner: I set the concept, composition, palette and type, and it wrote the code that renders each visual — a procedural knot, a particle funnel, an animated storyboard. Code-generated art stays crisp at any size, animates for free and follows the brand system exactly, which image generators still struggle with.</a:t>
+              <a:t>I generated the character in Magnific, using the INFUSE character sheet as the reference, because a human figure is where AI illustration shines and a flat, limited-palette prompt keeps it on brand. Everything around her — knot, thread, funnel, storyboard — is built in code with Claude, so it stays crisp, animates, and follows the palette exactly.</a:t>
             </a:r>
           </a:p>
         </p:txBody>

</xml_diff>